<commit_message>
Clarify proposal skill reuse and vary the reference case
</commit_message>
<xml_diff>
--- a/public/business/proposals/past.pptx
+++ b/public/business/proposals/past.pptx
@@ -2,15 +2,15 @@
 <file path=ppt/presentation.xml><?xml version="1.0" encoding="utf-8"?>
 <p:presentation xmlns:p="http://schemas.openxmlformats.org/presentationml/2006/main">
   <p:sldMasterIdLst>
-    <p:sldMasterId xmlns:r="http://schemas.openxmlformats.org/officeDocument/2006/relationships" id="2147483648" r:id="R0966eee04fdd4e61"/>
+    <p:sldMasterId xmlns:r="http://schemas.openxmlformats.org/officeDocument/2006/relationships" id="2147483648" r:id="Rddb6265c0e16403d"/>
   </p:sldMasterIdLst>
   <p:notesMasterIdLst>
-    <p:notesMasterId xmlns:r="http://schemas.openxmlformats.org/officeDocument/2006/relationships" r:id="R1843d2f9417d47c2"/>
+    <p:notesMasterId xmlns:r="http://schemas.openxmlformats.org/officeDocument/2006/relationships" r:id="R7dfb75fc235a4d45"/>
   </p:notesMasterIdLst>
   <p:sldIdLst>
-    <p:sldId xmlns:r="http://schemas.openxmlformats.org/officeDocument/2006/relationships" id="256" r:id="R6f93a3927e964013"/>
-    <p:sldId xmlns:r="http://schemas.openxmlformats.org/officeDocument/2006/relationships" id="257" r:id="R4b3ce4ce614d423a"/>
-    <p:sldId xmlns:r="http://schemas.openxmlformats.org/officeDocument/2006/relationships" id="258" r:id="Rc19ca1b37b334415"/>
+    <p:sldId xmlns:r="http://schemas.openxmlformats.org/officeDocument/2006/relationships" id="256" r:id="R127a2995e86b4578"/>
+    <p:sldId xmlns:r="http://schemas.openxmlformats.org/officeDocument/2006/relationships" id="257" r:id="R111a93b7a3bf4095"/>
+    <p:sldId xmlns:r="http://schemas.openxmlformats.org/officeDocument/2006/relationships" id="258" r:id="R95266dc37fe84100"/>
   </p:sldIdLst>
   <p:sldSz cx="12192000" cy="6858000"/>
   <p:notesSz cx="6858000" cy="9144000"/>
@@ -444,7 +444,7 @@
           <a:lstStyle xmlns:a="http://schemas.openxmlformats.org/drawingml/2006/main"/>
           <a:p xmlns:a="http://schemas.openxmlformats.org/drawingml/2006/main">
             <a:r>
-              <a:t>サンプル企業の提案資料。サイト画面はscripts/proposal-samples/site.htmlを撮影した現状・改善案。写真出典: Craig Lovelidge https://unsplash.com/photos/bV5dFLEYecM / Slidebean https://unsplash.com/photos/6MtJ-y1hzTs。実在の受注実績ではない。</a:t>
+              <a:t>サンプル企業の提案資料。サイト画面はscripts/proposal-samples/recruitment.htmlを撮影した現状・改善案。写真出典: Craig Lovelidge https://unsplash.com/photos/bV5dFLEYecM / Slidebean https://unsplash.com/photos/6MtJ-y1hzTs。実在の受注実績ではない。</a:t>
             </a:r>
           </a:p>
         </p:txBody>
@@ -514,7 +514,7 @@
           <a:lstStyle xmlns:a="http://schemas.openxmlformats.org/drawingml/2006/main"/>
           <a:p xmlns:a="http://schemas.openxmlformats.org/drawingml/2006/main">
             <a:r>
-              <a:t>サンプル企業の提案資料。サイト画面はscripts/proposal-samples/site.htmlを撮影した現状・改善案。写真出典: Craig Lovelidge https://unsplash.com/photos/bV5dFLEYecM / Slidebean https://unsplash.com/photos/6MtJ-y1hzTs。実在の受注実績ではない。</a:t>
+              <a:t>サンプル企業の提案資料。サイト画面はscripts/proposal-samples/recruitment.htmlを撮影した現状・改善案。写真出典: Craig Lovelidge https://unsplash.com/photos/bV5dFLEYecM / Slidebean https://unsplash.com/photos/6MtJ-y1hzTs。実在の受注実績ではない。</a:t>
             </a:r>
           </a:p>
         </p:txBody>
@@ -584,7 +584,7 @@
           <a:lstStyle xmlns:a="http://schemas.openxmlformats.org/drawingml/2006/main"/>
           <a:p xmlns:a="http://schemas.openxmlformats.org/drawingml/2006/main">
             <a:r>
-              <a:t>サンプル企業の提案資料。サイト画面はscripts/proposal-samples/site.htmlを撮影した現状・改善案。写真出典: Craig Lovelidge https://unsplash.com/photos/bV5dFLEYecM / Slidebean https://unsplash.com/photos/6MtJ-y1hzTs。実在の受注実績ではない。</a:t>
+              <a:t>サンプル企業の提案資料。サイト画面はscripts/proposal-samples/recruitment.htmlを撮影した現状・改善案。写真出典: Craig Lovelidge https://unsplash.com/photos/bV5dFLEYecM / Slidebean https://unsplash.com/photos/6MtJ-y1hzTs。実在の受注実績ではない。</a:t>
             </a:r>
           </a:p>
         </p:txBody>
@@ -631,7 +631,7 @@
           <p:cNvPr id="3" name="Title">
             <a:extLst xmlns:a="http://schemas.openxmlformats.org/drawingml/2006/main">
               <a:ext uri="{FF2B5EF4-FFF2-40B4-BE49-F238E27FC236}">
-                <a16:creationId xmlns:a16="http://schemas.microsoft.com/office/drawing/2014/main" id="{4A0A59FE-E355-4164-9263-3D3A58D55F2A}"/>
+                <a16:creationId xmlns:a16="http://schemas.microsoft.com/office/drawing/2014/main" id="{C411497B-3CD4-4C8D-973D-36AA5A5CE00B}"/>
               </a:ext>
             </a:extLst>
           </p:cNvPr>
@@ -860,7 +860,7 @@
           <p:cNvPr id="2" name="Subtitle">
             <a:extLst xmlns:a="http://schemas.openxmlformats.org/drawingml/2006/main">
               <a:ext uri="{FF2B5EF4-FFF2-40B4-BE49-F238E27FC236}">
-                <a16:creationId xmlns:a16="http://schemas.microsoft.com/office/drawing/2014/main" id="{B6B13ED9-659A-4FBA-9798-137BB6D10C12}"/>
+                <a16:creationId xmlns:a16="http://schemas.microsoft.com/office/drawing/2014/main" id="{E4ECB6A0-41D9-4F3D-A5A1-3CC9CD367DE1}"/>
               </a:ext>
             </a:extLst>
           </p:cNvPr>
@@ -1106,7 +1106,7 @@
           <p:cNvPr id="2" name="Section title">
             <a:extLst xmlns:a="http://schemas.openxmlformats.org/drawingml/2006/main">
               <a:ext uri="{FF2B5EF4-FFF2-40B4-BE49-F238E27FC236}">
-                <a16:creationId xmlns:a16="http://schemas.microsoft.com/office/drawing/2014/main" id="{5AE8C46D-279A-4B32-80FF-F9DC572D9C65}"/>
+                <a16:creationId xmlns:a16="http://schemas.microsoft.com/office/drawing/2014/main" id="{5A674ADF-55DB-4D5D-91A3-E8057D093977}"/>
               </a:ext>
             </a:extLst>
           </p:cNvPr>
@@ -1352,7 +1352,7 @@
           <p:cNvPr id="3" name="Title">
             <a:extLst xmlns:a="http://schemas.openxmlformats.org/drawingml/2006/main">
               <a:ext uri="{FF2B5EF4-FFF2-40B4-BE49-F238E27FC236}">
-                <a16:creationId xmlns:a16="http://schemas.microsoft.com/office/drawing/2014/main" id="{EA62367C-EFE3-47BE-94AE-C669757250D2}"/>
+                <a16:creationId xmlns:a16="http://schemas.microsoft.com/office/drawing/2014/main" id="{5F484A2A-DB5D-4EBE-8C98-5FC2F24949B2}"/>
               </a:ext>
             </a:extLst>
           </p:cNvPr>
@@ -1581,7 +1581,7 @@
           <p:cNvPr id="2" name="Body">
             <a:extLst xmlns:a="http://schemas.openxmlformats.org/drawingml/2006/main">
               <a:ext uri="{FF2B5EF4-FFF2-40B4-BE49-F238E27FC236}">
-                <a16:creationId xmlns:a16="http://schemas.microsoft.com/office/drawing/2014/main" id="{AE6F6149-8AD3-475D-AC53-CABA401D9992}"/>
+                <a16:creationId xmlns:a16="http://schemas.microsoft.com/office/drawing/2014/main" id="{345C0A09-D636-47DE-A1DB-8167B23AA4B1}"/>
               </a:ext>
             </a:extLst>
           </p:cNvPr>
@@ -1827,7 +1827,7 @@
           <p:cNvPr id="4" name="Title">
             <a:extLst xmlns:a="http://schemas.openxmlformats.org/drawingml/2006/main">
               <a:ext uri="{FF2B5EF4-FFF2-40B4-BE49-F238E27FC236}">
-                <a16:creationId xmlns:a16="http://schemas.microsoft.com/office/drawing/2014/main" id="{A1AB1DF0-B82A-4227-8D90-8F52662A3234}"/>
+                <a16:creationId xmlns:a16="http://schemas.microsoft.com/office/drawing/2014/main" id="{DFEDA38E-E144-4A8A-ACFD-C2B96CBDA189}"/>
               </a:ext>
             </a:extLst>
           </p:cNvPr>
@@ -2056,7 +2056,7 @@
           <p:cNvPr id="2" name="Left column">
             <a:extLst xmlns:a="http://schemas.openxmlformats.org/drawingml/2006/main">
               <a:ext uri="{FF2B5EF4-FFF2-40B4-BE49-F238E27FC236}">
-                <a16:creationId xmlns:a16="http://schemas.microsoft.com/office/drawing/2014/main" id="{A7A838B8-8EE5-463F-B80A-5DCCC411C0BF}"/>
+                <a16:creationId xmlns:a16="http://schemas.microsoft.com/office/drawing/2014/main" id="{C2BA401F-D52C-4CDB-8B45-8E71D8A7ADB2}"/>
               </a:ext>
             </a:extLst>
           </p:cNvPr>
@@ -2285,7 +2285,7 @@
           <p:cNvPr id="3" name="Right column">
             <a:extLst xmlns:a="http://schemas.openxmlformats.org/drawingml/2006/main">
               <a:ext uri="{FF2B5EF4-FFF2-40B4-BE49-F238E27FC236}">
-                <a16:creationId xmlns:a16="http://schemas.microsoft.com/office/drawing/2014/main" id="{440A929F-9857-473F-93C9-FB77C4B74A3D}"/>
+                <a16:creationId xmlns:a16="http://schemas.microsoft.com/office/drawing/2014/main" id="{F2EC7920-A6C4-449C-A18C-57E4AF8B1733}"/>
               </a:ext>
             </a:extLst>
           </p:cNvPr>
@@ -2531,7 +2531,7 @@
           <p:cNvPr id="3" name="Title">
             <a:extLst xmlns:a="http://schemas.openxmlformats.org/drawingml/2006/main">
               <a:ext uri="{FF2B5EF4-FFF2-40B4-BE49-F238E27FC236}">
-                <a16:creationId xmlns:a16="http://schemas.microsoft.com/office/drawing/2014/main" id="{F8538BF9-A2F2-4254-A063-DA44F7239215}"/>
+                <a16:creationId xmlns:a16="http://schemas.microsoft.com/office/drawing/2014/main" id="{4D56190B-A994-4D3B-B72F-25C1CF204D5C}"/>
               </a:ext>
             </a:extLst>
           </p:cNvPr>
@@ -2760,7 +2760,7 @@
           <p:cNvPr id="2" name="Left column">
             <a:extLst xmlns:a="http://schemas.openxmlformats.org/drawingml/2006/main">
               <a:ext uri="{FF2B5EF4-FFF2-40B4-BE49-F238E27FC236}">
-                <a16:creationId xmlns:a16="http://schemas.microsoft.com/office/drawing/2014/main" id="{55B60FD2-0918-4B43-9E21-D666C6EB2E53}"/>
+                <a16:creationId xmlns:a16="http://schemas.microsoft.com/office/drawing/2014/main" id="{0E8A7B3B-DDC1-4C05-8CD3-71BD17124DF8}"/>
               </a:ext>
             </a:extLst>
           </p:cNvPr>
@@ -3027,12 +3027,12 @@
   </p:cSld>
   <p:clrMap bg1="lt1" tx1="dk1" bg2="lt2" tx2="dk2" accent1="accent1" accent2="accent2" accent3="accent3" accent4="accent4" accent5="accent5" accent6="accent6" hlink="hlink" folHlink="folHlink"/>
   <p:sldLayoutIdLst>
-    <p:sldLayoutId xmlns:r="http://schemas.openxmlformats.org/officeDocument/2006/relationships" id="2147483649" r:id="R59ac7bfdb42341b2"/>
-    <p:sldLayoutId xmlns:r="http://schemas.openxmlformats.org/officeDocument/2006/relationships" id="2147483650" r:id="Re8453d3b0fb8426d"/>
-    <p:sldLayoutId xmlns:r="http://schemas.openxmlformats.org/officeDocument/2006/relationships" id="2147483651" r:id="R67a7433d9b3b4cd3"/>
-    <p:sldLayoutId xmlns:r="http://schemas.openxmlformats.org/officeDocument/2006/relationships" id="2147483652" r:id="R71475c1dfaf04e4e"/>
-    <p:sldLayoutId xmlns:r="http://schemas.openxmlformats.org/officeDocument/2006/relationships" id="2147483653" r:id="Raadd36ac7e834eeb"/>
-    <p:sldLayoutId xmlns:r="http://schemas.openxmlformats.org/officeDocument/2006/relationships" id="2147483654" r:id="R4a28ed1456a04a6d"/>
+    <p:sldLayoutId xmlns:r="http://schemas.openxmlformats.org/officeDocument/2006/relationships" id="2147483649" r:id="R98b34953d3a0459b"/>
+    <p:sldLayoutId xmlns:r="http://schemas.openxmlformats.org/officeDocument/2006/relationships" id="2147483650" r:id="R511332a89f194e4a"/>
+    <p:sldLayoutId xmlns:r="http://schemas.openxmlformats.org/officeDocument/2006/relationships" id="2147483651" r:id="Ra04744cc4be34a11"/>
+    <p:sldLayoutId xmlns:r="http://schemas.openxmlformats.org/officeDocument/2006/relationships" id="2147483652" r:id="R114d3d7a08c648f9"/>
+    <p:sldLayoutId xmlns:r="http://schemas.openxmlformats.org/officeDocument/2006/relationships" id="2147483653" r:id="Rd67db628a48641b5"/>
+    <p:sldLayoutId xmlns:r="http://schemas.openxmlformats.org/officeDocument/2006/relationships" id="2147483654" r:id="R8be701adad9143ef"/>
   </p:sldLayoutIdLst>
   <p:txStyles>
     <p:titleStyle>
@@ -3583,7 +3583,7 @@
           <p:cNvPr id="13" name="">
             <a:extLst xmlns:a="http://schemas.openxmlformats.org/drawingml/2006/main">
               <a:ext uri="{FF2B5EF4-FFF2-40B4-BE49-F238E27FC236}">
-                <a16:creationId xmlns:a16="http://schemas.microsoft.com/office/drawing/2014/main" id="{DA9DE07A-3D97-4850-B48D-E5E90D178175}"/>
+                <a16:creationId xmlns:a16="http://schemas.microsoft.com/office/drawing/2014/main" id="{2DD4F8F4-F4A6-460F-AEE4-D589D1D714B8}"/>
               </a:ext>
             </a:extLst>
           </p:cNvPr>
@@ -3742,7 +3742,7 @@
           <p:cNvPr id="2" name="">
             <a:extLst xmlns:a="http://schemas.openxmlformats.org/drawingml/2006/main">
               <a:ext uri="{FF2B5EF4-FFF2-40B4-BE49-F238E27FC236}">
-                <a16:creationId xmlns:a16="http://schemas.microsoft.com/office/drawing/2014/main" id="{1B7B56AE-62D1-43EF-8C67-77EE2FEBB19D}"/>
+                <a16:creationId xmlns:a16="http://schemas.microsoft.com/office/drawing/2014/main" id="{F0513654-6683-42B4-AE2F-85D1BD0E09A7}"/>
               </a:ext>
             </a:extLst>
           </p:cNvPr>
@@ -3891,7 +3891,7 @@
                 <a:ea typeface="Noto Sans JP"/>
                 <a:cs typeface="Noto Sans JP"/>
               </a:rPr>
-              <a:t>こはるオフィス様　Webサイト改修のご提案</a:t>
+              <a:t>こはるオフィス様　採用ページ改善のご提案</a:t>
             </a:r>
           </a:p>
         </p:txBody>
@@ -3901,7 +3901,7 @@
           <p:cNvPr id="3" name="">
             <a:extLst xmlns:a="http://schemas.openxmlformats.org/drawingml/2006/main">
               <a:ext uri="{FF2B5EF4-FFF2-40B4-BE49-F238E27FC236}">
-                <a16:creationId xmlns:a16="http://schemas.microsoft.com/office/drawing/2014/main" id="{0E2E85FC-EA1C-4778-B5F5-83715F0BB8D4}"/>
+                <a16:creationId xmlns:a16="http://schemas.microsoft.com/office/drawing/2014/main" id="{93290393-5E14-4A8D-9281-90733073FF25}"/>
               </a:ext>
             </a:extLst>
           </p:cNvPr>
@@ -4050,7 +4050,7 @@
                 <a:ea typeface="Noto Sans JP"/>
                 <a:cs typeface="Noto Sans JP"/>
               </a:rPr>
-              <a:t>移転サービスの内容を、スマホでも読みやすく</a:t>
+              <a:t>募集条件を、職種ごとに比べやすく</a:t>
             </a:r>
           </a:p>
         </p:txBody>
@@ -4060,7 +4060,7 @@
           <p:cNvPr id="4" name="">
             <a:extLst xmlns:a="http://schemas.openxmlformats.org/drawingml/2006/main">
               <a:ext uri="{FF2B5EF4-FFF2-40B4-BE49-F238E27FC236}">
-                <a16:creationId xmlns:a16="http://schemas.microsoft.com/office/drawing/2014/main" id="{13D93793-C9A1-4A00-9AE9-89BAFC9F8ADC}"/>
+                <a16:creationId xmlns:a16="http://schemas.microsoft.com/office/drawing/2014/main" id="{6C2E7F21-8CF1-4EA2-9ECC-8B11B958F037}"/>
               </a:ext>
             </a:extLst>
           </p:cNvPr>
@@ -4219,7 +4219,7 @@
           <p:cNvPr id="5" name="">
             <a:extLst xmlns:a="http://schemas.openxmlformats.org/drawingml/2006/main">
               <a:ext uri="{FF2B5EF4-FFF2-40B4-BE49-F238E27FC236}">
-                <a16:creationId xmlns:a16="http://schemas.microsoft.com/office/drawing/2014/main" id="{C315210A-F32B-4F4C-B553-3ABCB6F74377}"/>
+                <a16:creationId xmlns:a16="http://schemas.microsoft.com/office/drawing/2014/main" id="{40C2E52F-51E0-4C1B-9DE3-A6A6EEFE3FF2}"/>
               </a:ext>
             </a:extLst>
           </p:cNvPr>
@@ -4378,7 +4378,7 @@
           <p:cNvPr id="6" name="">
             <a:extLst xmlns:a="http://schemas.openxmlformats.org/drawingml/2006/main">
               <a:ext uri="{FF2B5EF4-FFF2-40B4-BE49-F238E27FC236}">
-                <a16:creationId xmlns:a16="http://schemas.microsoft.com/office/drawing/2014/main" id="{32BE2117-2D7F-4F59-AEAD-8E9DC8EB700D}"/>
+                <a16:creationId xmlns:a16="http://schemas.microsoft.com/office/drawing/2014/main" id="{9A88C4C1-C62D-40CF-AB9C-2AA1F707A63E}"/>
               </a:ext>
             </a:extLst>
           </p:cNvPr>
@@ -4537,7 +4537,7 @@
           <p:cNvPr id="7" name="">
             <a:extLst xmlns:a="http://schemas.openxmlformats.org/drawingml/2006/main">
               <a:ext uri="{FF2B5EF4-FFF2-40B4-BE49-F238E27FC236}">
-                <a16:creationId xmlns:a16="http://schemas.microsoft.com/office/drawing/2014/main" id="{56CDBCA9-45D1-4FAA-9560-598161BD3B3F}"/>
+                <a16:creationId xmlns:a16="http://schemas.microsoft.com/office/drawing/2014/main" id="{60ADA890-AEC8-40A7-B2D3-41F3461DF079}"/>
               </a:ext>
             </a:extLst>
           </p:cNvPr>
@@ -4547,13 +4547,13 @@
           <p:nvPr/>
         </p:nvPicPr>
         <p:blipFill>
-          <a:blip xmlns:r="http://schemas.openxmlformats.org/officeDocument/2006/relationships" xmlns:a="http://schemas.openxmlformats.org/drawingml/2006/main" r:embed="R473693c724354ec7"/>
+          <a:blip xmlns:r="http://schemas.openxmlformats.org/officeDocument/2006/relationships" xmlns:a="http://schemas.openxmlformats.org/drawingml/2006/main" r:embed="Rf81af1677d104e58"/>
           <a:stretch xmlns:a="http://schemas.openxmlformats.org/drawingml/2006/main"/>
         </p:blipFill>
         <p:spPr>
           <a:xfrm xmlns:a="http://schemas.openxmlformats.org/drawingml/2006/main">
-            <a:off x="2123895" y="1885950"/>
-            <a:ext cx="1962509" cy="2667000"/>
+            <a:off x="954344" y="1885950"/>
+            <a:ext cx="4301613" cy="2667000"/>
           </a:xfrm>
           <a:prstGeom xmlns:a="http://schemas.openxmlformats.org/drawingml/2006/main" prst="rect">
             <a:avLst/>
@@ -4565,7 +4565,7 @@
           <p:cNvPr id="8" name="">
             <a:extLst xmlns:a="http://schemas.openxmlformats.org/drawingml/2006/main">
               <a:ext uri="{FF2B5EF4-FFF2-40B4-BE49-F238E27FC236}">
-                <a16:creationId xmlns:a16="http://schemas.microsoft.com/office/drawing/2014/main" id="{6D5FF3DB-5F25-47C4-A699-C86B29E1673B}"/>
+                <a16:creationId xmlns:a16="http://schemas.microsoft.com/office/drawing/2014/main" id="{B7AC5D0B-F630-4F87-93EC-410219C1F2F5}"/>
               </a:ext>
             </a:extLst>
           </p:cNvPr>
@@ -4714,7 +4714,7 @@
                 <a:ea typeface="Noto Sans JP"/>
                 <a:cs typeface="Noto Sans JP"/>
               </a:rPr>
-              <a:t>スマホでもPCと同じ幅で表示され、サービスの説明が小さくなっています。</a:t>
+              <a:t>営業職と事務職の条件が長い文章に混在し、自分に合う募集を探しにくい状態です。</a:t>
             </a:r>
           </a:p>
         </p:txBody>
@@ -4724,7 +4724,7 @@
           <p:cNvPr id="9" name="">
             <a:extLst xmlns:a="http://schemas.openxmlformats.org/drawingml/2006/main">
               <a:ext uri="{FF2B5EF4-FFF2-40B4-BE49-F238E27FC236}">
-                <a16:creationId xmlns:a16="http://schemas.microsoft.com/office/drawing/2014/main" id="{468F811D-E7D9-4E30-9B16-4DF6521DFFAB}"/>
+                <a16:creationId xmlns:a16="http://schemas.microsoft.com/office/drawing/2014/main" id="{6F8C2FB7-7E9F-49F4-853D-2A61477992F2}"/>
               </a:ext>
             </a:extLst>
           </p:cNvPr>
@@ -4883,7 +4883,7 @@
           <p:cNvPr id="10" name="">
             <a:extLst xmlns:a="http://schemas.openxmlformats.org/drawingml/2006/main">
               <a:ext uri="{FF2B5EF4-FFF2-40B4-BE49-F238E27FC236}">
-                <a16:creationId xmlns:a16="http://schemas.microsoft.com/office/drawing/2014/main" id="{D0259908-C3AE-4764-8BCC-E8C1992124D5}"/>
+                <a16:creationId xmlns:a16="http://schemas.microsoft.com/office/drawing/2014/main" id="{8FF8C611-D985-43A0-8049-161A2CAD9152}"/>
               </a:ext>
             </a:extLst>
           </p:cNvPr>
@@ -4893,13 +4893,13 @@
           <p:nvPr/>
         </p:nvPicPr>
         <p:blipFill>
-          <a:blip xmlns:r="http://schemas.openxmlformats.org/officeDocument/2006/relationships" xmlns:a="http://schemas.openxmlformats.org/drawingml/2006/main" r:embed="Rd230a2bd00da4e22"/>
+          <a:blip xmlns:r="http://schemas.openxmlformats.org/officeDocument/2006/relationships" xmlns:a="http://schemas.openxmlformats.org/drawingml/2006/main" r:embed="R04f10db0b5d64b47"/>
           <a:stretch xmlns:a="http://schemas.openxmlformats.org/drawingml/2006/main"/>
         </p:blipFill>
         <p:spPr>
           <a:xfrm xmlns:a="http://schemas.openxmlformats.org/drawingml/2006/main">
-            <a:off x="7915095" y="1885950"/>
-            <a:ext cx="1962509" cy="2667000"/>
+            <a:off x="6745544" y="1885950"/>
+            <a:ext cx="4301613" cy="2667000"/>
           </a:xfrm>
           <a:prstGeom xmlns:a="http://schemas.openxmlformats.org/drawingml/2006/main" prst="rect">
             <a:avLst/>
@@ -4911,7 +4911,7 @@
           <p:cNvPr id="11" name="">
             <a:extLst xmlns:a="http://schemas.openxmlformats.org/drawingml/2006/main">
               <a:ext uri="{FF2B5EF4-FFF2-40B4-BE49-F238E27FC236}">
-                <a16:creationId xmlns:a16="http://schemas.microsoft.com/office/drawing/2014/main" id="{F314B88C-2B10-4A2C-8EF0-4A324D9BE792}"/>
+                <a16:creationId xmlns:a16="http://schemas.microsoft.com/office/drawing/2014/main" id="{099144F2-AFFA-4C3E-8EBC-5E986AB664DA}"/>
               </a:ext>
             </a:extLst>
           </p:cNvPr>
@@ -5060,7 +5060,7 @@
                 <a:ea typeface="Noto Sans JP"/>
                 <a:cs typeface="Noto Sans JP"/>
               </a:rPr>
-              <a:t>スマホでは文章と画像を縦に並べ、移転・レイアウト・設置の対応範囲を読みやすく整理します。</a:t>
+              <a:t>仕事内容・給与・勤務時間を職種ごとに並べ、条件を見比べられるようにします。</a:t>
             </a:r>
           </a:p>
         </p:txBody>
@@ -5070,7 +5070,7 @@
           <p:cNvPr id="12" name="">
             <a:extLst xmlns:a="http://schemas.openxmlformats.org/drawingml/2006/main">
               <a:ext uri="{FF2B5EF4-FFF2-40B4-BE49-F238E27FC236}">
-                <a16:creationId xmlns:a16="http://schemas.microsoft.com/office/drawing/2014/main" id="{74612797-5B4B-4705-8EF8-6598CB55E0CF}"/>
+                <a16:creationId xmlns:a16="http://schemas.microsoft.com/office/drawing/2014/main" id="{EDC4B540-B29A-4003-A534-CF1F0EF0C6AE}"/>
               </a:ext>
             </a:extLst>
           </p:cNvPr>
@@ -5219,7 +5219,7 @@
                 <a:ea typeface="Noto Sans JP"/>
                 <a:cs typeface="Noto Sans JP"/>
               </a:rPr>
-              <a:t>本文16pxを基準に、見出しと本文の差を明確にする。</a:t>
+              <a:t>募集要項を2職種に分けて掲載します。条件は最新の採用情報をご支給ください。</a:t>
             </a:r>
           </a:p>
         </p:txBody>
@@ -5227,7 +5227,7 @@
     </p:spTree>
     <p:extLst>
       <p:ext uri="{BB962C8B-B14F-4D97-AF65-F5344CB8AC3E}">
-        <p14:creationId xmlns:p14="http://schemas.microsoft.com/office/powerpoint/2010/main" val="1734771876"/>
+        <p14:creationId xmlns:p14="http://schemas.microsoft.com/office/powerpoint/2010/main" val="1463592375"/>
       </p:ext>
     </p:extLst>
   </p:cSld>
@@ -5258,7 +5258,7 @@
           <p:cNvPr id="13" name="">
             <a:extLst xmlns:a="http://schemas.openxmlformats.org/drawingml/2006/main">
               <a:ext uri="{FF2B5EF4-FFF2-40B4-BE49-F238E27FC236}">
-                <a16:creationId xmlns:a16="http://schemas.microsoft.com/office/drawing/2014/main" id="{35AEDB9A-CC38-42CB-B301-CEEE112A6D7E}"/>
+                <a16:creationId xmlns:a16="http://schemas.microsoft.com/office/drawing/2014/main" id="{23099011-DE04-4482-A1B0-595F56EB4D56}"/>
               </a:ext>
             </a:extLst>
           </p:cNvPr>
@@ -5417,7 +5417,7 @@
           <p:cNvPr id="2" name="">
             <a:extLst xmlns:a="http://schemas.openxmlformats.org/drawingml/2006/main">
               <a:ext uri="{FF2B5EF4-FFF2-40B4-BE49-F238E27FC236}">
-                <a16:creationId xmlns:a16="http://schemas.microsoft.com/office/drawing/2014/main" id="{58D8C12C-9E5B-44C4-991F-F0479D11EFA9}"/>
+                <a16:creationId xmlns:a16="http://schemas.microsoft.com/office/drawing/2014/main" id="{DE250387-DE55-4690-806D-42F29EC01318}"/>
               </a:ext>
             </a:extLst>
           </p:cNvPr>
@@ -5566,7 +5566,7 @@
                 <a:ea typeface="Noto Sans JP"/>
                 <a:cs typeface="Noto Sans JP"/>
               </a:rPr>
-              <a:t>こはるオフィス様　Webサイト改修のご提案</a:t>
+              <a:t>こはるオフィス様　採用ページ改善のご提案</a:t>
             </a:r>
           </a:p>
         </p:txBody>
@@ -5576,7 +5576,7 @@
           <p:cNvPr id="3" name="">
             <a:extLst xmlns:a="http://schemas.openxmlformats.org/drawingml/2006/main">
               <a:ext uri="{FF2B5EF4-FFF2-40B4-BE49-F238E27FC236}">
-                <a16:creationId xmlns:a16="http://schemas.microsoft.com/office/drawing/2014/main" id="{5F3F2906-B901-4B2D-94F7-F285627C5358}"/>
+                <a16:creationId xmlns:a16="http://schemas.microsoft.com/office/drawing/2014/main" id="{24E1421F-03FF-4C9D-96AD-C3C89BC3CDF5}"/>
               </a:ext>
             </a:extLst>
           </p:cNvPr>
@@ -5725,7 +5725,7 @@
                 <a:ea typeface="Noto Sans JP"/>
                 <a:cs typeface="Noto Sans JP"/>
               </a:rPr>
-              <a:t>移転の相談へ進める入口を、説明のすぐ下に</a:t>
+              <a:t>入社後の一日が想像できる仕事紹介</a:t>
             </a:r>
           </a:p>
         </p:txBody>
@@ -5735,7 +5735,7 @@
           <p:cNvPr id="4" name="">
             <a:extLst xmlns:a="http://schemas.openxmlformats.org/drawingml/2006/main">
               <a:ext uri="{FF2B5EF4-FFF2-40B4-BE49-F238E27FC236}">
-                <a16:creationId xmlns:a16="http://schemas.microsoft.com/office/drawing/2014/main" id="{6D08C364-EE49-4EC1-87B7-F54DBB6EAA7C}"/>
+                <a16:creationId xmlns:a16="http://schemas.microsoft.com/office/drawing/2014/main" id="{14E6EF8F-2A96-47C7-A221-34317D5479BA}"/>
               </a:ext>
             </a:extLst>
           </p:cNvPr>
@@ -5894,7 +5894,7 @@
           <p:cNvPr id="5" name="">
             <a:extLst xmlns:a="http://schemas.openxmlformats.org/drawingml/2006/main">
               <a:ext uri="{FF2B5EF4-FFF2-40B4-BE49-F238E27FC236}">
-                <a16:creationId xmlns:a16="http://schemas.microsoft.com/office/drawing/2014/main" id="{41085904-637C-4B39-90DE-77C5E91671CA}"/>
+                <a16:creationId xmlns:a16="http://schemas.microsoft.com/office/drawing/2014/main" id="{F8765AFF-EEA8-4DB2-B139-6798285F5A61}"/>
               </a:ext>
             </a:extLst>
           </p:cNvPr>
@@ -6053,7 +6053,7 @@
           <p:cNvPr id="6" name="">
             <a:extLst xmlns:a="http://schemas.openxmlformats.org/drawingml/2006/main">
               <a:ext uri="{FF2B5EF4-FFF2-40B4-BE49-F238E27FC236}">
-                <a16:creationId xmlns:a16="http://schemas.microsoft.com/office/drawing/2014/main" id="{ED2EC789-6B16-4236-90B9-1B9154010A0B}"/>
+                <a16:creationId xmlns:a16="http://schemas.microsoft.com/office/drawing/2014/main" id="{DC9C9DA8-C11E-4726-BC9A-679EEF740003}"/>
               </a:ext>
             </a:extLst>
           </p:cNvPr>
@@ -6212,7 +6212,7 @@
           <p:cNvPr id="7" name="">
             <a:extLst xmlns:a="http://schemas.openxmlformats.org/drawingml/2006/main">
               <a:ext uri="{FF2B5EF4-FFF2-40B4-BE49-F238E27FC236}">
-                <a16:creationId xmlns:a16="http://schemas.microsoft.com/office/drawing/2014/main" id="{B1F599A9-4D09-4330-9A88-8EECAE32ADEB}"/>
+                <a16:creationId xmlns:a16="http://schemas.microsoft.com/office/drawing/2014/main" id="{BA468D42-E813-4061-8859-7F93904CEF05}"/>
               </a:ext>
             </a:extLst>
           </p:cNvPr>
@@ -6222,7 +6222,7 @@
           <p:nvPr/>
         </p:nvPicPr>
         <p:blipFill>
-          <a:blip xmlns:r="http://schemas.openxmlformats.org/officeDocument/2006/relationships" xmlns:a="http://schemas.openxmlformats.org/drawingml/2006/main" r:embed="R0641e71430ae4a99"/>
+          <a:blip xmlns:r="http://schemas.openxmlformats.org/officeDocument/2006/relationships" xmlns:a="http://schemas.openxmlformats.org/drawingml/2006/main" r:embed="R7f7a6532d4924712"/>
           <a:stretch xmlns:a="http://schemas.openxmlformats.org/drawingml/2006/main"/>
         </p:blipFill>
         <p:spPr>
@@ -6240,7 +6240,7 @@
           <p:cNvPr id="8" name="">
             <a:extLst xmlns:a="http://schemas.openxmlformats.org/drawingml/2006/main">
               <a:ext uri="{FF2B5EF4-FFF2-40B4-BE49-F238E27FC236}">
-                <a16:creationId xmlns:a16="http://schemas.microsoft.com/office/drawing/2014/main" id="{F6956F84-AAD7-4DB9-8F6B-E2A5AA32F25D}"/>
+                <a16:creationId xmlns:a16="http://schemas.microsoft.com/office/drawing/2014/main" id="{5AE9FC20-D0B3-4D81-91F8-FD1FCF6F2E01}"/>
               </a:ext>
             </a:extLst>
           </p:cNvPr>
@@ -6389,7 +6389,7 @@
                 <a:ea typeface="Noto Sans JP"/>
                 <a:cs typeface="Noto Sans JP"/>
               </a:rPr>
-              <a:t>サービスページの末尾は「担当者へお問い合わせください」の文章だけです。</a:t>
+              <a:t>「営業業務全般」という説明だけでは、具体的に何をする仕事か分かりません。</a:t>
             </a:r>
           </a:p>
         </p:txBody>
@@ -6399,7 +6399,7 @@
           <p:cNvPr id="9" name="">
             <a:extLst xmlns:a="http://schemas.openxmlformats.org/drawingml/2006/main">
               <a:ext uri="{FF2B5EF4-FFF2-40B4-BE49-F238E27FC236}">
-                <a16:creationId xmlns:a16="http://schemas.microsoft.com/office/drawing/2014/main" id="{6CA47C61-CF95-4E03-859D-13BCAC3E99CA}"/>
+                <a16:creationId xmlns:a16="http://schemas.microsoft.com/office/drawing/2014/main" id="{8F6D3C0E-A21C-42BF-91EF-023275B90E88}"/>
               </a:ext>
             </a:extLst>
           </p:cNvPr>
@@ -6558,7 +6558,7 @@
           <p:cNvPr id="10" name="">
             <a:extLst xmlns:a="http://schemas.openxmlformats.org/drawingml/2006/main">
               <a:ext uri="{FF2B5EF4-FFF2-40B4-BE49-F238E27FC236}">
-                <a16:creationId xmlns:a16="http://schemas.microsoft.com/office/drawing/2014/main" id="{DD3A6D8C-A41F-4AB7-BEDA-DDACD912FC22}"/>
+                <a16:creationId xmlns:a16="http://schemas.microsoft.com/office/drawing/2014/main" id="{6670BA77-F920-43F8-8090-7025A62D7725}"/>
               </a:ext>
             </a:extLst>
           </p:cNvPr>
@@ -6568,7 +6568,7 @@
           <p:nvPr/>
         </p:nvPicPr>
         <p:blipFill>
-          <a:blip xmlns:r="http://schemas.openxmlformats.org/officeDocument/2006/relationships" xmlns:a="http://schemas.openxmlformats.org/drawingml/2006/main" r:embed="Rcc6d9645d4854d12"/>
+          <a:blip xmlns:r="http://schemas.openxmlformats.org/officeDocument/2006/relationships" xmlns:a="http://schemas.openxmlformats.org/drawingml/2006/main" r:embed="R7d15338e2e5f4f72"/>
           <a:stretch xmlns:a="http://schemas.openxmlformats.org/drawingml/2006/main"/>
         </p:blipFill>
         <p:spPr>
@@ -6586,7 +6586,7 @@
           <p:cNvPr id="11" name="">
             <a:extLst xmlns:a="http://schemas.openxmlformats.org/drawingml/2006/main">
               <a:ext uri="{FF2B5EF4-FFF2-40B4-BE49-F238E27FC236}">
-                <a16:creationId xmlns:a16="http://schemas.microsoft.com/office/drawing/2014/main" id="{54CB7114-96D4-4C5E-8E9A-B812D218299D}"/>
+                <a16:creationId xmlns:a16="http://schemas.microsoft.com/office/drawing/2014/main" id="{11244060-BE63-457A-8415-846C9FDC180F}"/>
               </a:ext>
             </a:extLst>
           </p:cNvPr>
@@ -6735,7 +6735,7 @@
                 <a:ea typeface="Noto Sans JP"/>
                 <a:cs typeface="Noto Sans JP"/>
               </a:rPr>
-              <a:t>ページ末尾に専用の相談ボタンを設けます。「図面がなくても相談できる」と添え、初期検討の段階でも連絡できることを伝えます。</a:t>
+              <a:t>出社から退社までの流れと、訪問・提案準備などの業務を写真付きで紹介します。</a:t>
             </a:r>
           </a:p>
         </p:txBody>
@@ -6745,7 +6745,7 @@
           <p:cNvPr id="12" name="">
             <a:extLst xmlns:a="http://schemas.openxmlformats.org/drawingml/2006/main">
               <a:ext uri="{FF2B5EF4-FFF2-40B4-BE49-F238E27FC236}">
-                <a16:creationId xmlns:a16="http://schemas.microsoft.com/office/drawing/2014/main" id="{48A32F0D-5B20-4A66-9BB8-AD5FF07B01A9}"/>
+                <a16:creationId xmlns:a16="http://schemas.microsoft.com/office/drawing/2014/main" id="{607700AA-A0BE-48DF-8FBB-3106F21BD46C}"/>
               </a:ext>
             </a:extLst>
           </p:cNvPr>
@@ -6894,7 +6894,7 @@
                 <a:ea typeface="Noto Sans JP"/>
                 <a:cs typeface="Noto Sans JP"/>
               </a:rPr>
-              <a:t>ヘッダーとサービス説明の末尾から、同じフォームへ誘導。</a:t>
+              <a:t>営業職の「一日の流れ」を1ページ追加します。社員の原稿と写真をご支給ください。</a:t>
             </a:r>
           </a:p>
         </p:txBody>
@@ -6902,7 +6902,7 @@
     </p:spTree>
     <p:extLst>
       <p:ext uri="{BB962C8B-B14F-4D97-AF65-F5344CB8AC3E}">
-        <p14:creationId xmlns:p14="http://schemas.microsoft.com/office/powerpoint/2010/main" val="63866569"/>
+        <p14:creationId xmlns:p14="http://schemas.microsoft.com/office/powerpoint/2010/main" val="1763742222"/>
       </p:ext>
     </p:extLst>
   </p:cSld>
@@ -6933,7 +6933,7 @@
           <p:cNvPr id="13" name="">
             <a:extLst xmlns:a="http://schemas.openxmlformats.org/drawingml/2006/main">
               <a:ext uri="{FF2B5EF4-FFF2-40B4-BE49-F238E27FC236}">
-                <a16:creationId xmlns:a16="http://schemas.microsoft.com/office/drawing/2014/main" id="{FD6811A9-6741-49C7-92B3-DE128A326F7F}"/>
+                <a16:creationId xmlns:a16="http://schemas.microsoft.com/office/drawing/2014/main" id="{148EC67B-8A9C-4D5B-8D47-24A67E0D5372}"/>
               </a:ext>
             </a:extLst>
           </p:cNvPr>
@@ -7092,7 +7092,7 @@
           <p:cNvPr id="2" name="">
             <a:extLst xmlns:a="http://schemas.openxmlformats.org/drawingml/2006/main">
               <a:ext uri="{FF2B5EF4-FFF2-40B4-BE49-F238E27FC236}">
-                <a16:creationId xmlns:a16="http://schemas.microsoft.com/office/drawing/2014/main" id="{A2461FD0-61D8-4A1A-97E1-791C67309150}"/>
+                <a16:creationId xmlns:a16="http://schemas.microsoft.com/office/drawing/2014/main" id="{62427555-1E5B-461B-903E-278FB4E1FDC9}"/>
               </a:ext>
             </a:extLst>
           </p:cNvPr>
@@ -7241,7 +7241,7 @@
                 <a:ea typeface="Noto Sans JP"/>
                 <a:cs typeface="Noto Sans JP"/>
               </a:rPr>
-              <a:t>こはるオフィス様　Webサイト改修のご提案</a:t>
+              <a:t>こはるオフィス様　採用ページ改善のご提案</a:t>
             </a:r>
           </a:p>
         </p:txBody>
@@ -7251,7 +7251,7 @@
           <p:cNvPr id="3" name="">
             <a:extLst xmlns:a="http://schemas.openxmlformats.org/drawingml/2006/main">
               <a:ext uri="{FF2B5EF4-FFF2-40B4-BE49-F238E27FC236}">
-                <a16:creationId xmlns:a16="http://schemas.microsoft.com/office/drawing/2014/main" id="{A2824F81-E813-40AF-8451-CD502BBA7FCC}"/>
+                <a16:creationId xmlns:a16="http://schemas.microsoft.com/office/drawing/2014/main" id="{A468BF2D-8C35-42C4-842E-FEA92F8E73C6}"/>
               </a:ext>
             </a:extLst>
           </p:cNvPr>
@@ -7400,7 +7400,7 @@
                 <a:ea typeface="Noto Sans JP"/>
                 <a:cs typeface="Noto Sans JP"/>
               </a:rPr>
-              <a:t>移転後の様子が分かる2事例を掲載</a:t>
+              <a:t>初回の応募は、連絡に必要な項目だけに</a:t>
             </a:r>
           </a:p>
         </p:txBody>
@@ -7410,7 +7410,7 @@
           <p:cNvPr id="4" name="">
             <a:extLst xmlns:a="http://schemas.openxmlformats.org/drawingml/2006/main">
               <a:ext uri="{FF2B5EF4-FFF2-40B4-BE49-F238E27FC236}">
-                <a16:creationId xmlns:a16="http://schemas.microsoft.com/office/drawing/2014/main" id="{C40F35A4-A589-4E57-9FE6-AAFDBD35F483}"/>
+                <a16:creationId xmlns:a16="http://schemas.microsoft.com/office/drawing/2014/main" id="{90DBE234-C343-499B-B991-4C73CCC440EE}"/>
               </a:ext>
             </a:extLst>
           </p:cNvPr>
@@ -7569,7 +7569,7 @@
           <p:cNvPr id="5" name="">
             <a:extLst xmlns:a="http://schemas.openxmlformats.org/drawingml/2006/main">
               <a:ext uri="{FF2B5EF4-FFF2-40B4-BE49-F238E27FC236}">
-                <a16:creationId xmlns:a16="http://schemas.microsoft.com/office/drawing/2014/main" id="{0A0C1424-22F9-4AC0-B7A7-13D1E1209B27}"/>
+                <a16:creationId xmlns:a16="http://schemas.microsoft.com/office/drawing/2014/main" id="{4A8F91D1-FBA0-42D3-A117-DD69FDF46721}"/>
               </a:ext>
             </a:extLst>
           </p:cNvPr>
@@ -7728,7 +7728,7 @@
           <p:cNvPr id="6" name="">
             <a:extLst xmlns:a="http://schemas.openxmlformats.org/drawingml/2006/main">
               <a:ext uri="{FF2B5EF4-FFF2-40B4-BE49-F238E27FC236}">
-                <a16:creationId xmlns:a16="http://schemas.microsoft.com/office/drawing/2014/main" id="{DE0BBE30-B217-4A62-A8ED-7730C3471108}"/>
+                <a16:creationId xmlns:a16="http://schemas.microsoft.com/office/drawing/2014/main" id="{017F12ED-51AC-4C1F-BDB3-662410F74B5A}"/>
               </a:ext>
             </a:extLst>
           </p:cNvPr>
@@ -7887,7 +7887,7 @@
           <p:cNvPr id="7" name="">
             <a:extLst xmlns:a="http://schemas.openxmlformats.org/drawingml/2006/main">
               <a:ext uri="{FF2B5EF4-FFF2-40B4-BE49-F238E27FC236}">
-                <a16:creationId xmlns:a16="http://schemas.microsoft.com/office/drawing/2014/main" id="{342DCAFD-7B01-4CA5-9E2A-1A5EC909F8E1}"/>
+                <a16:creationId xmlns:a16="http://schemas.microsoft.com/office/drawing/2014/main" id="{830A0142-B714-4D59-8FB2-2EBC5DBD4CC0}"/>
               </a:ext>
             </a:extLst>
           </p:cNvPr>
@@ -7897,7 +7897,7 @@
           <p:nvPr/>
         </p:nvPicPr>
         <p:blipFill>
-          <a:blip xmlns:r="http://schemas.openxmlformats.org/officeDocument/2006/relationships" xmlns:a="http://schemas.openxmlformats.org/drawingml/2006/main" r:embed="R99758bca2cff4bd0"/>
+          <a:blip xmlns:r="http://schemas.openxmlformats.org/officeDocument/2006/relationships" xmlns:a="http://schemas.openxmlformats.org/drawingml/2006/main" r:embed="Rcd39b567291c46a8"/>
           <a:stretch xmlns:a="http://schemas.openxmlformats.org/drawingml/2006/main"/>
         </p:blipFill>
         <p:spPr>
@@ -7915,7 +7915,7 @@
           <p:cNvPr id="8" name="">
             <a:extLst xmlns:a="http://schemas.openxmlformats.org/drawingml/2006/main">
               <a:ext uri="{FF2B5EF4-FFF2-40B4-BE49-F238E27FC236}">
-                <a16:creationId xmlns:a16="http://schemas.microsoft.com/office/drawing/2014/main" id="{AB564743-77DC-49CA-AA78-37E4240C7FA7}"/>
+                <a16:creationId xmlns:a16="http://schemas.microsoft.com/office/drawing/2014/main" id="{3B432B19-67E6-4BBB-8060-9EF136AF5517}"/>
               </a:ext>
             </a:extLst>
           </p:cNvPr>
@@ -8064,7 +8064,7 @@
                 <a:ea typeface="Noto Sans JP"/>
                 <a:cs typeface="Noto Sans JP"/>
               </a:rPr>
-              <a:t>古い納品報告だけでは、レイアウト相談まで対応していることが伝わりません。</a:t>
+              <a:t>応募時に職歴の詳しい入力と履歴書の添付が必須で、すぐには申し込めません。</a:t>
             </a:r>
           </a:p>
         </p:txBody>
@@ -8074,7 +8074,7 @@
           <p:cNvPr id="9" name="">
             <a:extLst xmlns:a="http://schemas.openxmlformats.org/drawingml/2006/main">
               <a:ext uri="{FF2B5EF4-FFF2-40B4-BE49-F238E27FC236}">
-                <a16:creationId xmlns:a16="http://schemas.microsoft.com/office/drawing/2014/main" id="{B0887C5B-D83C-42F3-A090-BD025C2F805D}"/>
+                <a16:creationId xmlns:a16="http://schemas.microsoft.com/office/drawing/2014/main" id="{9084D2D3-DDAA-4977-9339-3DCEC3FCD10A}"/>
               </a:ext>
             </a:extLst>
           </p:cNvPr>
@@ -8233,7 +8233,7 @@
           <p:cNvPr id="10" name="">
             <a:extLst xmlns:a="http://schemas.openxmlformats.org/drawingml/2006/main">
               <a:ext uri="{FF2B5EF4-FFF2-40B4-BE49-F238E27FC236}">
-                <a16:creationId xmlns:a16="http://schemas.microsoft.com/office/drawing/2014/main" id="{E5DAF16B-4D49-4F50-8C89-B65FCF2633A1}"/>
+                <a16:creationId xmlns:a16="http://schemas.microsoft.com/office/drawing/2014/main" id="{B2015489-36C6-4A0B-AC66-C013CE36A681}"/>
               </a:ext>
             </a:extLst>
           </p:cNvPr>
@@ -8243,7 +8243,7 @@
           <p:nvPr/>
         </p:nvPicPr>
         <p:blipFill>
-          <a:blip xmlns:r="http://schemas.openxmlformats.org/officeDocument/2006/relationships" xmlns:a="http://schemas.openxmlformats.org/drawingml/2006/main" r:embed="Rfd62ba471f35466b"/>
+          <a:blip xmlns:r="http://schemas.openxmlformats.org/officeDocument/2006/relationships" xmlns:a="http://schemas.openxmlformats.org/drawingml/2006/main" r:embed="Rd8656c04d2bd4880"/>
           <a:stretch xmlns:a="http://schemas.openxmlformats.org/drawingml/2006/main"/>
         </p:blipFill>
         <p:spPr>
@@ -8261,7 +8261,7 @@
           <p:cNvPr id="11" name="">
             <a:extLst xmlns:a="http://schemas.openxmlformats.org/drawingml/2006/main">
               <a:ext uri="{FF2B5EF4-FFF2-40B4-BE49-F238E27FC236}">
-                <a16:creationId xmlns:a16="http://schemas.microsoft.com/office/drawing/2014/main" id="{C451842F-DF71-421F-837E-6FFEE28B72EC}"/>
+                <a16:creationId xmlns:a16="http://schemas.microsoft.com/office/drawing/2014/main" id="{62C70F95-3BBB-462C-85C5-690C26BD2405}"/>
               </a:ext>
             </a:extLst>
           </p:cNvPr>
@@ -8410,7 +8410,7 @@
                 <a:ea typeface="Noto Sans JP"/>
                 <a:cs typeface="Noto Sans JP"/>
               </a:rPr>
-              <a:t>執務スペースと会議室の2事例を、写真と相談の背景を添えて紹介します。納品した物だけでなく、対応した内容を説明します。</a:t>
+              <a:t>氏名・連絡先・希望職種で応募できるようにし、履歴書は面談前の提出に変えます。</a:t>
             </a:r>
           </a:p>
         </p:txBody>
@@ -8420,7 +8420,7 @@
           <p:cNvPr id="12" name="">
             <a:extLst xmlns:a="http://schemas.openxmlformats.org/drawingml/2006/main">
               <a:ext uri="{FF2B5EF4-FFF2-40B4-BE49-F238E27FC236}">
-                <a16:creationId xmlns:a16="http://schemas.microsoft.com/office/drawing/2014/main" id="{A1759199-7252-4359-9D32-35EA65910E43}"/>
+                <a16:creationId xmlns:a16="http://schemas.microsoft.com/office/drawing/2014/main" id="{FCE7FB7B-6037-46F9-B90C-B33922EDFF44}"/>
               </a:ext>
             </a:extLst>
           </p:cNvPr>
@@ -8569,7 +8569,7 @@
                 <a:ea typeface="Noto Sans JP"/>
                 <a:cs typeface="Noto Sans JP"/>
               </a:rPr>
-              <a:t>写真・対象人数・相談内容を、同じ項目で整理。</a:t>
+              <a:t>既存応募フォームの必須項目と案内文を変更します。書類提出の方法は別途確認します。</a:t>
             </a:r>
           </a:p>
         </p:txBody>
@@ -8577,7 +8577,7 @@
     </p:spTree>
     <p:extLst>
       <p:ext uri="{BB962C8B-B14F-4D97-AF65-F5344CB8AC3E}">
-        <p14:creationId xmlns:p14="http://schemas.microsoft.com/office/powerpoint/2010/main" val="43893452"/>
+        <p14:creationId xmlns:p14="http://schemas.microsoft.com/office/powerpoint/2010/main" val="2072003978"/>
       </p:ext>
     </p:extLst>
   </p:cSld>

</xml_diff>